<commit_message>
Publish reproducible credit-model audit and experiment pipeline
Add the development-only nested-CV workflow, transparent model benchmarks,
preprocessing and imbalance ablations, independent calibration and threshold
selection, and SHAP/LIME diagnostics. Include portable historical exclusions,
fold-level evidence, tests, CI, model/data cards and report-generation sources.

Validate a clean staged export with 19 tests and complete primary/adaptive
refits. Recorded settings, outer metrics and development predictions match;
document small inner L1 search-score variation without claiming bitwise
search reproducibility. Preserve historical files and local-only theory PDF.
</commit_message>
<xml_diff>
--- a/reports/portfolio_v1/results_presentation.pptx
+++ b/reports/portfolio_v1/results_presentation.pptx
@@ -23806,7 +23806,7 @@
               </a:defRPr>
             </a:pPr>
             <a:r>
-              <a:t>Cold refits: two complete recipes, six folds, both calibration modes reproduce saved</a:t>
+              <a:t>Refit checks are distinct from saved-model checks; inner L1 search scores vary slightly</a:t>
             </a:r>
           </a:p>
         </p:txBody>
@@ -23845,7 +23845,7 @@
               </a:defRPr>
             </a:pPr>
             <a:r>
-              <a:t>predictions.</a:t>
+              <a:t>between runs.</a:t>
             </a:r>
           </a:p>
         </p:txBody>
@@ -23927,7 +23927,7 @@
               </a:defRPr>
             </a:pPr>
             <a:r>
-              <a:t>Tracked plan, fold tables, failures, runtimes, environment, hashes and code snapshots;</a:t>
+              <a:t>Published code, plan, fold tables, runtimes, environment and presentation; original run</a:t>
             </a:r>
           </a:p>
         </p:txBody>
@@ -23966,7 +23966,7 @@
               </a:defRPr>
             </a:pPr>
             <a:r>
-              <a:t>PDFs remain local.</a:t>
+              <a:t>snapshots and theory PDF stay local.</a:t>
             </a:r>
           </a:p>
         </p:txBody>
@@ -25142,7 +25142,7 @@
               </a:defRPr>
             </a:pPr>
             <a:r>
-              <a:t>Local reports/portfolio_v1: presentation, theory PDF, technical-report PDF, charts and</a:t>
+              <a:t>GitHub reports/portfolio_v1: presentation PDF and PowerPoint. Theory PDF, technical-report</a:t>
             </a:r>
           </a:p>
         </p:txBody>
@@ -25181,7 +25181,7 @@
               </a:defRPr>
             </a:pPr>
             <a:r>
-              <a:t>validation previews.</a:t>
+              <a:t>PDF, charts and previews stay local.</a:t>
             </a:r>
           </a:p>
         </p:txBody>

</xml_diff>